<commit_message>
Ground invisible-identity work in the Woman-Centered Coaching Transformation Matrix
Update Zammit teaching with the real 'I'm Invisible' pattern (key mechanism,
indicators, limiting beliefs) and its positive pole: presencing and the
'I see myself / I am present' power statements. Add two Session 1 slides
(I see myself. I am present. / I take my place).

Co-Authored-By: Claude Opus 4.8 <noreply@anthropic.com>
Claude-Session: https://claude.ai/code/session_01FhNN1xnUyELSQ3xs2X22yA
</commit_message>
<xml_diff>
--- a/content/sessions/slides/Session-1-Coming-Home-to-Yourself.pptx
+++ b/content/sessions/slides/Session-1-Coming-Home-to-Yourself.pptx
@@ -25,6 +25,8 @@
     <p:sldId id="273" r:id="rId24"/>
     <p:sldId id="274" r:id="rId25"/>
     <p:sldId id="275" r:id="rId26"/>
+    <p:sldId id="276" r:id="rId27"/>
+    <p:sldId id="277" r:id="rId28"/>
   </p:sldIdLst>
   <p:sldSz cx="12191695" cy="6858000" type="screen4x3"/>
   <p:notesSz cx="6858000" cy="9144000"/>
@@ -3491,7 +3493,7 @@
     <p:bg>
       <p:bgPr>
         <a:solidFill>
-          <a:srgbClr val="9E4A2A"/>
+          <a:srgbClr val="C2A46D"/>
         </a:solidFill>
         <a:effectLst/>
       </p:bgPr>
@@ -3528,11 +3530,11 @@
             <a:r>
               <a:rPr sz="1500" b="1">
                 <a:solidFill>
-                  <a:srgbClr val="C2A46D"/>
+                  <a:srgbClr val="6E1A2E"/>
                 </a:solidFill>
                 <a:latin typeface="Lora"/>
               </a:rPr>
-              <a:t>IN PAIRS</a:t>
+              <a:t>THE SHIFT  ·  PRESENCING</a:t>
             </a:r>
           </a:p>
         </p:txBody>
@@ -3562,11 +3564,11 @@
             <a:r>
               <a:rPr sz="4000">
                 <a:solidFill>
-                  <a:srgbClr val="F5EFE3"/>
+                  <a:srgbClr val="15110D"/>
                 </a:solidFill>
                 <a:latin typeface="Marcellus"/>
               </a:rPr>
-              <a:t>Breakout · How I make myself invisible</a:t>
+              <a:t>I see myself. I am present.</a:t>
             </a:r>
           </a:p>
         </p:txBody>
@@ -3586,7 +3588,7 @@
             <a:avLst/>
           </a:prstGeom>
           <a:solidFill>
-            <a:srgbClr val="C2A46D"/>
+            <a:srgbClr val="6E1A2E"/>
           </a:solidFill>
           <a:ln>
             <a:noFill/>
@@ -3643,61 +3645,13 @@
               </a:spcAft>
             </a:pPr>
             <a:r>
-              <a:rPr sz="2300" i="0">
-                <a:solidFill>
-                  <a:srgbClr val="F5EFE3"/>
+              <a:rPr sz="2700" i="1">
+                <a:solidFill>
+                  <a:srgbClr val="15110D"/>
                 </a:solidFill>
                 <a:latin typeface="Lora"/>
               </a:rPr>
-              <a:t>•  One way I make myself invisible is...</a:t>
-            </a:r>
-          </a:p>
-          <a:p>
-            <a:pPr>
-              <a:spcAft>
-                <a:spcPts val="1200"/>
-              </a:spcAft>
-            </a:pPr>
-            <a:r>
-              <a:rPr sz="2300" i="0">
-                <a:solidFill>
-                  <a:srgbClr val="F5EFE3"/>
-                </a:solidFill>
-                <a:latin typeface="Lora"/>
-              </a:rPr>
-              <a:t>•  One way I've trained people not to see my needs is...</a:t>
-            </a:r>
-          </a:p>
-          <a:p>
-            <a:pPr>
-              <a:spcAft>
-                <a:spcPts val="1200"/>
-              </a:spcAft>
-            </a:pPr>
-            <a:r>
-              <a:rPr sz="2300" i="0">
-                <a:solidFill>
-                  <a:srgbClr val="F5EFE3"/>
-                </a:solidFill>
-                <a:latin typeface="Lora"/>
-              </a:rPr>
-              <a:t>•  The story underneath might be... (invisible / not enough / too much / a burden)</a:t>
-            </a:r>
-          </a:p>
-          <a:p>
-            <a:pPr>
-              <a:spcAft>
-                <a:spcPts val="1200"/>
-              </a:spcAft>
-            </a:pPr>
-            <a:r>
-              <a:rPr sz="2300" i="0">
-                <a:solidFill>
-                  <a:srgbClr val="F5EFE3"/>
-                </a:solidFill>
-                <a:latin typeface="Lora"/>
-              </a:rPr>
-              <a:t>•  Partner: just witness. Then swap.</a:t>
+              <a:t>I stop waiting to be seen. I turn toward myself, and I make myself visible. It is my destiny to be visible.</a:t>
             </a:r>
           </a:p>
         </p:txBody>
@@ -3727,7 +3681,7 @@
             <a:r>
               <a:rPr sz="1100">
                 <a:solidFill>
-                  <a:srgbClr val="C2A46D"/>
+                  <a:srgbClr val="6E1A2E"/>
                 </a:solidFill>
                 <a:latin typeface="Lora"/>
               </a:rPr>
@@ -3745,6 +3699,265 @@
 </file>
 
 <file path=ppt/slides/slide12.xml><?xml version="1.0" encoding="utf-8"?>
+<p:sld xmlns:a="http://schemas.openxmlformats.org/drawingml/2006/main" xmlns:p="http://schemas.openxmlformats.org/presentationml/2006/main" xmlns:r="http://schemas.openxmlformats.org/officeDocument/2006/relationships">
+  <p:cSld>
+    <p:bg>
+      <p:bgPr>
+        <a:solidFill>
+          <a:srgbClr val="9E4A2A"/>
+        </a:solidFill>
+        <a:effectLst/>
+      </p:bgPr>
+    </p:bg>
+    <p:spTree>
+      <p:nvGrpSpPr>
+        <p:cNvPr id="1" name=""/>
+        <p:cNvGrpSpPr/>
+        <p:nvPr/>
+      </p:nvGrpSpPr>
+      <p:grpSpPr/>
+      <p:sp>
+        <p:nvSpPr>
+          <p:cNvPr id="2" name="TextBox 1"/>
+          <p:cNvSpPr txBox="1"/>
+          <p:nvPr/>
+        </p:nvSpPr>
+        <p:spPr>
+          <a:xfrm>
+            <a:off x="822960" y="548640"/>
+            <a:ext cx="10515600" cy="457200"/>
+          </a:xfrm>
+          <a:prstGeom prst="rect">
+            <a:avLst/>
+          </a:prstGeom>
+          <a:noFill/>
+        </p:spPr>
+        <p:txBody>
+          <a:bodyPr wrap="none">
+            <a:spAutoFit/>
+          </a:bodyPr>
+          <a:lstStyle/>
+          <a:p>
+            <a:r>
+              <a:rPr sz="1500" b="1">
+                <a:solidFill>
+                  <a:srgbClr val="C2A46D"/>
+                </a:solidFill>
+                <a:latin typeface="Lora"/>
+              </a:rPr>
+              <a:t>IN PAIRS</a:t>
+            </a:r>
+          </a:p>
+        </p:txBody>
+      </p:sp>
+      <p:sp>
+        <p:nvSpPr>
+          <p:cNvPr id="3" name="TextBox 2"/>
+          <p:cNvSpPr txBox="1"/>
+          <p:nvPr/>
+        </p:nvSpPr>
+        <p:spPr>
+          <a:xfrm>
+            <a:off x="822960" y="1005840"/>
+            <a:ext cx="10515600" cy="2926080"/>
+          </a:xfrm>
+          <a:prstGeom prst="rect">
+            <a:avLst/>
+          </a:prstGeom>
+          <a:noFill/>
+        </p:spPr>
+        <p:txBody>
+          <a:bodyPr wrap="square" anchor="t">
+            <a:spAutoFit/>
+          </a:bodyPr>
+          <a:lstStyle/>
+          <a:p>
+            <a:r>
+              <a:rPr sz="4000">
+                <a:solidFill>
+                  <a:srgbClr val="F5EFE3"/>
+                </a:solidFill>
+                <a:latin typeface="Marcellus"/>
+              </a:rPr>
+              <a:t>Breakout · How I make myself invisible</a:t>
+            </a:r>
+          </a:p>
+        </p:txBody>
+      </p:sp>
+      <p:sp>
+        <p:nvSpPr>
+          <p:cNvPr id="4" name="Rectangle 3"/>
+          <p:cNvSpPr/>
+          <p:nvPr/>
+        </p:nvSpPr>
+        <p:spPr>
+          <a:xfrm>
+            <a:off x="822960" y="2834640"/>
+            <a:ext cx="1463040" cy="38100"/>
+          </a:xfrm>
+          <a:prstGeom prst="rect">
+            <a:avLst/>
+          </a:prstGeom>
+          <a:solidFill>
+            <a:srgbClr val="C2A46D"/>
+          </a:solidFill>
+          <a:ln>
+            <a:noFill/>
+          </a:ln>
+          <a:effectLst/>
+        </p:spPr>
+        <p:style>
+          <a:lnRef idx="1">
+            <a:schemeClr val="accent1"/>
+          </a:lnRef>
+          <a:fillRef idx="3">
+            <a:schemeClr val="accent1"/>
+          </a:fillRef>
+          <a:effectRef idx="2">
+            <a:schemeClr val="accent1"/>
+          </a:effectRef>
+          <a:fontRef idx="minor">
+            <a:schemeClr val="lt1"/>
+          </a:fontRef>
+        </p:style>
+        <p:txBody>
+          <a:bodyPr rtlCol="0" anchor="ctr"/>
+          <a:lstStyle/>
+          <a:p>
+            <a:pPr algn="ctr"/>
+          </a:p>
+        </p:txBody>
+      </p:sp>
+      <p:sp>
+        <p:nvSpPr>
+          <p:cNvPr id="5" name="TextBox 4"/>
+          <p:cNvSpPr txBox="1"/>
+          <p:nvPr/>
+        </p:nvSpPr>
+        <p:spPr>
+          <a:xfrm>
+            <a:off x="822960" y="3154680"/>
+            <a:ext cx="10515600" cy="2926080"/>
+          </a:xfrm>
+          <a:prstGeom prst="rect">
+            <a:avLst/>
+          </a:prstGeom>
+          <a:noFill/>
+        </p:spPr>
+        <p:txBody>
+          <a:bodyPr wrap="square">
+            <a:spAutoFit/>
+          </a:bodyPr>
+          <a:lstStyle/>
+          <a:p>
+            <a:pPr>
+              <a:spcAft>
+                <a:spcPts val="1200"/>
+              </a:spcAft>
+            </a:pPr>
+            <a:r>
+              <a:rPr sz="2300" i="0">
+                <a:solidFill>
+                  <a:srgbClr val="F5EFE3"/>
+                </a:solidFill>
+                <a:latin typeface="Lora"/>
+              </a:rPr>
+              <a:t>•  One way I make myself invisible is...</a:t>
+            </a:r>
+          </a:p>
+          <a:p>
+            <a:pPr>
+              <a:spcAft>
+                <a:spcPts val="1200"/>
+              </a:spcAft>
+            </a:pPr>
+            <a:r>
+              <a:rPr sz="2300" i="0">
+                <a:solidFill>
+                  <a:srgbClr val="F5EFE3"/>
+                </a:solidFill>
+                <a:latin typeface="Lora"/>
+              </a:rPr>
+              <a:t>•  One way I've trained people not to see my needs is...</a:t>
+            </a:r>
+          </a:p>
+          <a:p>
+            <a:pPr>
+              <a:spcAft>
+                <a:spcPts val="1200"/>
+              </a:spcAft>
+            </a:pPr>
+            <a:r>
+              <a:rPr sz="2300" i="0">
+                <a:solidFill>
+                  <a:srgbClr val="F5EFE3"/>
+                </a:solidFill>
+                <a:latin typeface="Lora"/>
+              </a:rPr>
+              <a:t>•  The story underneath might be... (invisible / not enough / too much / a burden)</a:t>
+            </a:r>
+          </a:p>
+          <a:p>
+            <a:pPr>
+              <a:spcAft>
+                <a:spcPts val="1200"/>
+              </a:spcAft>
+            </a:pPr>
+            <a:r>
+              <a:rPr sz="2300" i="0">
+                <a:solidFill>
+                  <a:srgbClr val="F5EFE3"/>
+                </a:solidFill>
+                <a:latin typeface="Lora"/>
+              </a:rPr>
+              <a:t>•  Partner: just witness. Then swap.</a:t>
+            </a:r>
+          </a:p>
+        </p:txBody>
+      </p:sp>
+      <p:sp>
+        <p:nvSpPr>
+          <p:cNvPr id="6" name="TextBox 5"/>
+          <p:cNvSpPr txBox="1"/>
+          <p:nvPr/>
+        </p:nvSpPr>
+        <p:spPr>
+          <a:xfrm>
+            <a:off x="822960" y="6263640"/>
+            <a:ext cx="10515600" cy="365760"/>
+          </a:xfrm>
+          <a:prstGeom prst="rect">
+            <a:avLst/>
+          </a:prstGeom>
+          <a:noFill/>
+        </p:spPr>
+        <p:txBody>
+          <a:bodyPr wrap="none">
+            <a:spAutoFit/>
+          </a:bodyPr>
+          <a:lstStyle/>
+          <a:p>
+            <a:r>
+              <a:rPr sz="1100">
+                <a:solidFill>
+                  <a:srgbClr val="C2A46D"/>
+                </a:solidFill>
+                <a:latin typeface="Lora"/>
+              </a:rPr>
+              <a:t>SEXUALEMPOWERMENTFORWOMEN.COM</a:t>
+            </a:r>
+          </a:p>
+        </p:txBody>
+      </p:sp>
+    </p:spTree>
+  </p:cSld>
+  <p:clrMapOvr>
+    <a:masterClrMapping/>
+  </p:clrMapOvr>
+</p:sld>
+</file>
+
+<file path=ppt/slides/slide13.xml><?xml version="1.0" encoding="utf-8"?>
 <p:sld xmlns:a="http://schemas.openxmlformats.org/drawingml/2006/main" xmlns:p="http://schemas.openxmlformats.org/presentationml/2006/main" xmlns:r="http://schemas.openxmlformats.org/officeDocument/2006/relationships">
   <p:cSld>
     <p:bg>
@@ -3955,7 +4168,7 @@
 </p:sld>
 </file>
 
-<file path=ppt/slides/slide13.xml><?xml version="1.0" encoding="utf-8"?>
+<file path=ppt/slides/slide14.xml><?xml version="1.0" encoding="utf-8"?>
 <p:sld xmlns:a="http://schemas.openxmlformats.org/drawingml/2006/main" xmlns:p="http://schemas.openxmlformats.org/presentationml/2006/main" xmlns:r="http://schemas.openxmlformats.org/officeDocument/2006/relationships">
   <p:cSld>
     <p:bg>
@@ -4198,7 +4411,7 @@
 </p:sld>
 </file>
 
-<file path=ppt/slides/slide14.xml><?xml version="1.0" encoding="utf-8"?>
+<file path=ppt/slides/slide15.xml><?xml version="1.0" encoding="utf-8"?>
 <p:sld xmlns:a="http://schemas.openxmlformats.org/drawingml/2006/main" xmlns:p="http://schemas.openxmlformats.org/presentationml/2006/main" xmlns:r="http://schemas.openxmlformats.org/officeDocument/2006/relationships">
   <p:cSld>
     <p:bg>
@@ -4409,7 +4622,7 @@
 </p:sld>
 </file>
 
-<file path=ppt/slides/slide15.xml><?xml version="1.0" encoding="utf-8"?>
+<file path=ppt/slides/slide16.xml><?xml version="1.0" encoding="utf-8"?>
 <p:sld xmlns:a="http://schemas.openxmlformats.org/drawingml/2006/main" xmlns:p="http://schemas.openxmlformats.org/presentationml/2006/main" xmlns:r="http://schemas.openxmlformats.org/officeDocument/2006/relationships">
   <p:cSld>
     <p:bg>
@@ -4652,7 +4865,7 @@
 </p:sld>
 </file>
 
-<file path=ppt/slides/slide16.xml><?xml version="1.0" encoding="utf-8"?>
+<file path=ppt/slides/slide17.xml><?xml version="1.0" encoding="utf-8"?>
 <p:sld xmlns:a="http://schemas.openxmlformats.org/drawingml/2006/main" xmlns:p="http://schemas.openxmlformats.org/presentationml/2006/main" xmlns:r="http://schemas.openxmlformats.org/officeDocument/2006/relationships">
   <p:cSld>
     <p:bg>
@@ -4863,7 +5076,7 @@
 </p:sld>
 </file>
 
-<file path=ppt/slides/slide17.xml><?xml version="1.0" encoding="utf-8"?>
+<file path=ppt/slides/slide18.xml><?xml version="1.0" encoding="utf-8"?>
 <p:sld xmlns:a="http://schemas.openxmlformats.org/drawingml/2006/main" xmlns:p="http://schemas.openxmlformats.org/presentationml/2006/main" xmlns:r="http://schemas.openxmlformats.org/officeDocument/2006/relationships">
   <p:cSld>
     <p:bg>
@@ -5040,7 +5253,7 @@
 </p:sld>
 </file>
 
-<file path=ppt/slides/slide18.xml><?xml version="1.0" encoding="utf-8"?>
+<file path=ppt/slides/slide19.xml><?xml version="1.0" encoding="utf-8"?>
 <p:sld xmlns:a="http://schemas.openxmlformats.org/drawingml/2006/main" xmlns:p="http://schemas.openxmlformats.org/presentationml/2006/main" xmlns:r="http://schemas.openxmlformats.org/officeDocument/2006/relationships">
   <p:cSld>
     <p:bg>
@@ -5201,183 +5414,6 @@
               <a:rPr sz="1100">
                 <a:solidFill>
                   <a:srgbClr val="6E1A2E"/>
-                </a:solidFill>
-                <a:latin typeface="Lora"/>
-              </a:rPr>
-              <a:t>SEXUALEMPOWERMENTFORWOMEN.COM</a:t>
-            </a:r>
-          </a:p>
-        </p:txBody>
-      </p:sp>
-    </p:spTree>
-  </p:cSld>
-  <p:clrMapOvr>
-    <a:masterClrMapping/>
-  </p:clrMapOvr>
-</p:sld>
-</file>
-
-<file path=ppt/slides/slide19.xml><?xml version="1.0" encoding="utf-8"?>
-<p:sld xmlns:a="http://schemas.openxmlformats.org/drawingml/2006/main" xmlns:p="http://schemas.openxmlformats.org/presentationml/2006/main" xmlns:r="http://schemas.openxmlformats.org/officeDocument/2006/relationships">
-  <p:cSld>
-    <p:bg>
-      <p:bgPr>
-        <a:solidFill>
-          <a:srgbClr val="6E1A2E"/>
-        </a:solidFill>
-        <a:effectLst/>
-      </p:bgPr>
-    </p:bg>
-    <p:spTree>
-      <p:nvGrpSpPr>
-        <p:cNvPr id="1" name=""/>
-        <p:cNvGrpSpPr/>
-        <p:nvPr/>
-      </p:nvGrpSpPr>
-      <p:grpSpPr/>
-      <p:sp>
-        <p:nvSpPr>
-          <p:cNvPr id="2" name="TextBox 1"/>
-          <p:cNvSpPr txBox="1"/>
-          <p:nvPr/>
-        </p:nvSpPr>
-        <p:spPr>
-          <a:xfrm>
-            <a:off x="822960" y="1005840"/>
-            <a:ext cx="10515600" cy="2926080"/>
-          </a:xfrm>
-          <a:prstGeom prst="rect">
-            <a:avLst/>
-          </a:prstGeom>
-          <a:noFill/>
-        </p:spPr>
-        <p:txBody>
-          <a:bodyPr wrap="square" anchor="t">
-            <a:spAutoFit/>
-          </a:bodyPr>
-          <a:lstStyle/>
-          <a:p>
-            <a:r>
-              <a:rPr sz="4000">
-                <a:solidFill>
-                  <a:srgbClr val="F5EFE3"/>
-                </a:solidFill>
-                <a:latin typeface="Marcellus"/>
-              </a:rPr>
-              <a:t>Claim your power</a:t>
-            </a:r>
-          </a:p>
-        </p:txBody>
-      </p:sp>
-      <p:sp>
-        <p:nvSpPr>
-          <p:cNvPr id="3" name="Rectangle 2"/>
-          <p:cNvSpPr/>
-          <p:nvPr/>
-        </p:nvSpPr>
-        <p:spPr>
-          <a:xfrm>
-            <a:off x="822960" y="2834640"/>
-            <a:ext cx="1463040" cy="38100"/>
-          </a:xfrm>
-          <a:prstGeom prst="rect">
-            <a:avLst/>
-          </a:prstGeom>
-          <a:solidFill>
-            <a:srgbClr val="C2A46D"/>
-          </a:solidFill>
-          <a:ln>
-            <a:noFill/>
-          </a:ln>
-          <a:effectLst/>
-        </p:spPr>
-        <p:style>
-          <a:lnRef idx="1">
-            <a:schemeClr val="accent1"/>
-          </a:lnRef>
-          <a:fillRef idx="3">
-            <a:schemeClr val="accent1"/>
-          </a:fillRef>
-          <a:effectRef idx="2">
-            <a:schemeClr val="accent1"/>
-          </a:effectRef>
-          <a:fontRef idx="minor">
-            <a:schemeClr val="lt1"/>
-          </a:fontRef>
-        </p:style>
-        <p:txBody>
-          <a:bodyPr rtlCol="0" anchor="ctr"/>
-          <a:lstStyle/>
-          <a:p>
-            <a:pPr algn="ctr"/>
-          </a:p>
-        </p:txBody>
-      </p:sp>
-      <p:sp>
-        <p:nvSpPr>
-          <p:cNvPr id="4" name="TextBox 3"/>
-          <p:cNvSpPr txBox="1"/>
-          <p:nvPr/>
-        </p:nvSpPr>
-        <p:spPr>
-          <a:xfrm>
-            <a:off x="822960" y="3154680"/>
-            <a:ext cx="10515600" cy="2926080"/>
-          </a:xfrm>
-          <a:prstGeom prst="rect">
-            <a:avLst/>
-          </a:prstGeom>
-          <a:noFill/>
-        </p:spPr>
-        <p:txBody>
-          <a:bodyPr wrap="square">
-            <a:spAutoFit/>
-          </a:bodyPr>
-          <a:lstStyle/>
-          <a:p>
-            <a:pPr>
-              <a:spcAft>
-                <a:spcPts val="1200"/>
-              </a:spcAft>
-            </a:pPr>
-            <a:r>
-              <a:rPr sz="2700" i="1">
-                <a:solidFill>
-                  <a:srgbClr val="F5EFE3"/>
-                </a:solidFill>
-                <a:latin typeface="Lora"/>
-              </a:rPr>
-              <a:t>I'm powerful. I can create life. I can create the life I desire. The power is in my hands.</a:t>
-            </a:r>
-          </a:p>
-        </p:txBody>
-      </p:sp>
-      <p:sp>
-        <p:nvSpPr>
-          <p:cNvPr id="5" name="TextBox 4"/>
-          <p:cNvSpPr txBox="1"/>
-          <p:nvPr/>
-        </p:nvSpPr>
-        <p:spPr>
-          <a:xfrm>
-            <a:off x="822960" y="6263640"/>
-            <a:ext cx="10515600" cy="365760"/>
-          </a:xfrm>
-          <a:prstGeom prst="rect">
-            <a:avLst/>
-          </a:prstGeom>
-          <a:noFill/>
-        </p:spPr>
-        <p:txBody>
-          <a:bodyPr wrap="none">
-            <a:spAutoFit/>
-          </a:bodyPr>
-          <a:lstStyle/>
-          <a:p>
-            <a:r>
-              <a:rPr sz="1100">
-                <a:solidFill>
-                  <a:srgbClr val="C2A46D"/>
                 </a:solidFill>
                 <a:latin typeface="Lora"/>
               </a:rPr>
@@ -5577,6 +5613,394 @@
     <p:bg>
       <p:bgPr>
         <a:solidFill>
+          <a:srgbClr val="1F2A44"/>
+        </a:solidFill>
+        <a:effectLst/>
+      </p:bgPr>
+    </p:bg>
+    <p:spTree>
+      <p:nvGrpSpPr>
+        <p:cNvPr id="1" name=""/>
+        <p:cNvGrpSpPr/>
+        <p:nvPr/>
+      </p:nvGrpSpPr>
+      <p:grpSpPr/>
+      <p:sp>
+        <p:nvSpPr>
+          <p:cNvPr id="2" name="TextBox 1"/>
+          <p:cNvSpPr txBox="1"/>
+          <p:nvPr/>
+        </p:nvSpPr>
+        <p:spPr>
+          <a:xfrm>
+            <a:off x="822960" y="548640"/>
+            <a:ext cx="10515600" cy="457200"/>
+          </a:xfrm>
+          <a:prstGeom prst="rect">
+            <a:avLst/>
+          </a:prstGeom>
+          <a:noFill/>
+        </p:spPr>
+        <p:txBody>
+          <a:bodyPr wrap="none">
+            <a:spAutoFit/>
+          </a:bodyPr>
+          <a:lstStyle/>
+          <a:p>
+            <a:r>
+              <a:rPr sz="1500" b="1">
+                <a:solidFill>
+                  <a:srgbClr val="C2A46D"/>
+                </a:solidFill>
+                <a:latin typeface="Lora"/>
+              </a:rPr>
+              <a:t>THE POWER STATEMENT</a:t>
+            </a:r>
+          </a:p>
+        </p:txBody>
+      </p:sp>
+      <p:sp>
+        <p:nvSpPr>
+          <p:cNvPr id="3" name="TextBox 2"/>
+          <p:cNvSpPr txBox="1"/>
+          <p:nvPr/>
+        </p:nvSpPr>
+        <p:spPr>
+          <a:xfrm>
+            <a:off x="822960" y="1005840"/>
+            <a:ext cx="10515600" cy="2926080"/>
+          </a:xfrm>
+          <a:prstGeom prst="rect">
+            <a:avLst/>
+          </a:prstGeom>
+          <a:noFill/>
+        </p:spPr>
+        <p:txBody>
+          <a:bodyPr wrap="square" anchor="t">
+            <a:spAutoFit/>
+          </a:bodyPr>
+          <a:lstStyle/>
+          <a:p>
+            <a:r>
+              <a:rPr sz="4000">
+                <a:solidFill>
+                  <a:srgbClr val="F5EFE3"/>
+                </a:solidFill>
+                <a:latin typeface="Marcellus"/>
+              </a:rPr>
+              <a:t>I take my place</a:t>
+            </a:r>
+          </a:p>
+        </p:txBody>
+      </p:sp>
+      <p:sp>
+        <p:nvSpPr>
+          <p:cNvPr id="4" name="Rectangle 3"/>
+          <p:cNvSpPr/>
+          <p:nvPr/>
+        </p:nvSpPr>
+        <p:spPr>
+          <a:xfrm>
+            <a:off x="822960" y="2834640"/>
+            <a:ext cx="1463040" cy="38100"/>
+          </a:xfrm>
+          <a:prstGeom prst="rect">
+            <a:avLst/>
+          </a:prstGeom>
+          <a:solidFill>
+            <a:srgbClr val="C2A46D"/>
+          </a:solidFill>
+          <a:ln>
+            <a:noFill/>
+          </a:ln>
+          <a:effectLst/>
+        </p:spPr>
+        <p:style>
+          <a:lnRef idx="1">
+            <a:schemeClr val="accent1"/>
+          </a:lnRef>
+          <a:fillRef idx="3">
+            <a:schemeClr val="accent1"/>
+          </a:fillRef>
+          <a:effectRef idx="2">
+            <a:schemeClr val="accent1"/>
+          </a:effectRef>
+          <a:fontRef idx="minor">
+            <a:schemeClr val="lt1"/>
+          </a:fontRef>
+        </p:style>
+        <p:txBody>
+          <a:bodyPr rtlCol="0" anchor="ctr"/>
+          <a:lstStyle/>
+          <a:p>
+            <a:pPr algn="ctr"/>
+          </a:p>
+        </p:txBody>
+      </p:sp>
+      <p:sp>
+        <p:nvSpPr>
+          <p:cNvPr id="5" name="TextBox 4"/>
+          <p:cNvSpPr txBox="1"/>
+          <p:nvPr/>
+        </p:nvSpPr>
+        <p:spPr>
+          <a:xfrm>
+            <a:off x="822960" y="3154680"/>
+            <a:ext cx="10515600" cy="2926080"/>
+          </a:xfrm>
+          <a:prstGeom prst="rect">
+            <a:avLst/>
+          </a:prstGeom>
+          <a:noFill/>
+        </p:spPr>
+        <p:txBody>
+          <a:bodyPr wrap="square">
+            <a:spAutoFit/>
+          </a:bodyPr>
+          <a:lstStyle/>
+          <a:p>
+            <a:pPr>
+              <a:spcAft>
+                <a:spcPts val="1200"/>
+              </a:spcAft>
+            </a:pPr>
+            <a:r>
+              <a:rPr sz="2700" i="1">
+                <a:solidFill>
+                  <a:srgbClr val="F5EFE3"/>
+                </a:solidFill>
+                <a:latin typeface="Lora"/>
+              </a:rPr>
+              <a:t>I see myself. I am present to my own feelings, needs and desires. It is my destiny to be visible, and I take my rightful place.</a:t>
+            </a:r>
+          </a:p>
+        </p:txBody>
+      </p:sp>
+      <p:sp>
+        <p:nvSpPr>
+          <p:cNvPr id="6" name="TextBox 5"/>
+          <p:cNvSpPr txBox="1"/>
+          <p:nvPr/>
+        </p:nvSpPr>
+        <p:spPr>
+          <a:xfrm>
+            <a:off x="822960" y="6263640"/>
+            <a:ext cx="10515600" cy="365760"/>
+          </a:xfrm>
+          <a:prstGeom prst="rect">
+            <a:avLst/>
+          </a:prstGeom>
+          <a:noFill/>
+        </p:spPr>
+        <p:txBody>
+          <a:bodyPr wrap="none">
+            <a:spAutoFit/>
+          </a:bodyPr>
+          <a:lstStyle/>
+          <a:p>
+            <a:r>
+              <a:rPr sz="1100">
+                <a:solidFill>
+                  <a:srgbClr val="C2A46D"/>
+                </a:solidFill>
+                <a:latin typeface="Lora"/>
+              </a:rPr>
+              <a:t>SEXUALEMPOWERMENTFORWOMEN.COM</a:t>
+            </a:r>
+          </a:p>
+        </p:txBody>
+      </p:sp>
+    </p:spTree>
+  </p:cSld>
+  <p:clrMapOvr>
+    <a:masterClrMapping/>
+  </p:clrMapOvr>
+</p:sld>
+</file>
+
+<file path=ppt/slides/slide21.xml><?xml version="1.0" encoding="utf-8"?>
+<p:sld xmlns:a="http://schemas.openxmlformats.org/drawingml/2006/main" xmlns:p="http://schemas.openxmlformats.org/presentationml/2006/main" xmlns:r="http://schemas.openxmlformats.org/officeDocument/2006/relationships">
+  <p:cSld>
+    <p:bg>
+      <p:bgPr>
+        <a:solidFill>
+          <a:srgbClr val="6E1A2E"/>
+        </a:solidFill>
+        <a:effectLst/>
+      </p:bgPr>
+    </p:bg>
+    <p:spTree>
+      <p:nvGrpSpPr>
+        <p:cNvPr id="1" name=""/>
+        <p:cNvGrpSpPr/>
+        <p:nvPr/>
+      </p:nvGrpSpPr>
+      <p:grpSpPr/>
+      <p:sp>
+        <p:nvSpPr>
+          <p:cNvPr id="2" name="TextBox 1"/>
+          <p:cNvSpPr txBox="1"/>
+          <p:nvPr/>
+        </p:nvSpPr>
+        <p:spPr>
+          <a:xfrm>
+            <a:off x="822960" y="1005840"/>
+            <a:ext cx="10515600" cy="2926080"/>
+          </a:xfrm>
+          <a:prstGeom prst="rect">
+            <a:avLst/>
+          </a:prstGeom>
+          <a:noFill/>
+        </p:spPr>
+        <p:txBody>
+          <a:bodyPr wrap="square" anchor="t">
+            <a:spAutoFit/>
+          </a:bodyPr>
+          <a:lstStyle/>
+          <a:p>
+            <a:r>
+              <a:rPr sz="4000">
+                <a:solidFill>
+                  <a:srgbClr val="F5EFE3"/>
+                </a:solidFill>
+                <a:latin typeface="Marcellus"/>
+              </a:rPr>
+              <a:t>Claim your power</a:t>
+            </a:r>
+          </a:p>
+        </p:txBody>
+      </p:sp>
+      <p:sp>
+        <p:nvSpPr>
+          <p:cNvPr id="3" name="Rectangle 2"/>
+          <p:cNvSpPr/>
+          <p:nvPr/>
+        </p:nvSpPr>
+        <p:spPr>
+          <a:xfrm>
+            <a:off x="822960" y="2834640"/>
+            <a:ext cx="1463040" cy="38100"/>
+          </a:xfrm>
+          <a:prstGeom prst="rect">
+            <a:avLst/>
+          </a:prstGeom>
+          <a:solidFill>
+            <a:srgbClr val="C2A46D"/>
+          </a:solidFill>
+          <a:ln>
+            <a:noFill/>
+          </a:ln>
+          <a:effectLst/>
+        </p:spPr>
+        <p:style>
+          <a:lnRef idx="1">
+            <a:schemeClr val="accent1"/>
+          </a:lnRef>
+          <a:fillRef idx="3">
+            <a:schemeClr val="accent1"/>
+          </a:fillRef>
+          <a:effectRef idx="2">
+            <a:schemeClr val="accent1"/>
+          </a:effectRef>
+          <a:fontRef idx="minor">
+            <a:schemeClr val="lt1"/>
+          </a:fontRef>
+        </p:style>
+        <p:txBody>
+          <a:bodyPr rtlCol="0" anchor="ctr"/>
+          <a:lstStyle/>
+          <a:p>
+            <a:pPr algn="ctr"/>
+          </a:p>
+        </p:txBody>
+      </p:sp>
+      <p:sp>
+        <p:nvSpPr>
+          <p:cNvPr id="4" name="TextBox 3"/>
+          <p:cNvSpPr txBox="1"/>
+          <p:nvPr/>
+        </p:nvSpPr>
+        <p:spPr>
+          <a:xfrm>
+            <a:off x="822960" y="3154680"/>
+            <a:ext cx="10515600" cy="2926080"/>
+          </a:xfrm>
+          <a:prstGeom prst="rect">
+            <a:avLst/>
+          </a:prstGeom>
+          <a:noFill/>
+        </p:spPr>
+        <p:txBody>
+          <a:bodyPr wrap="square">
+            <a:spAutoFit/>
+          </a:bodyPr>
+          <a:lstStyle/>
+          <a:p>
+            <a:pPr>
+              <a:spcAft>
+                <a:spcPts val="1200"/>
+              </a:spcAft>
+            </a:pPr>
+            <a:r>
+              <a:rPr sz="2700" i="1">
+                <a:solidFill>
+                  <a:srgbClr val="F5EFE3"/>
+                </a:solidFill>
+                <a:latin typeface="Lora"/>
+              </a:rPr>
+              <a:t>I'm powerful. I can create life. I can create the life I desire. The power is in my hands.</a:t>
+            </a:r>
+          </a:p>
+        </p:txBody>
+      </p:sp>
+      <p:sp>
+        <p:nvSpPr>
+          <p:cNvPr id="5" name="TextBox 4"/>
+          <p:cNvSpPr txBox="1"/>
+          <p:nvPr/>
+        </p:nvSpPr>
+        <p:spPr>
+          <a:xfrm>
+            <a:off x="822960" y="6263640"/>
+            <a:ext cx="10515600" cy="365760"/>
+          </a:xfrm>
+          <a:prstGeom prst="rect">
+            <a:avLst/>
+          </a:prstGeom>
+          <a:noFill/>
+        </p:spPr>
+        <p:txBody>
+          <a:bodyPr wrap="none">
+            <a:spAutoFit/>
+          </a:bodyPr>
+          <a:lstStyle/>
+          <a:p>
+            <a:r>
+              <a:rPr sz="1100">
+                <a:solidFill>
+                  <a:srgbClr val="C2A46D"/>
+                </a:solidFill>
+                <a:latin typeface="Lora"/>
+              </a:rPr>
+              <a:t>SEXUALEMPOWERMENTFORWOMEN.COM</a:t>
+            </a:r>
+          </a:p>
+        </p:txBody>
+      </p:sp>
+    </p:spTree>
+  </p:cSld>
+  <p:clrMapOvr>
+    <a:masterClrMapping/>
+  </p:clrMapOvr>
+</p:sld>
+</file>
+
+<file path=ppt/slides/slide22.xml><?xml version="1.0" encoding="utf-8"?>
+<p:sld xmlns:a="http://schemas.openxmlformats.org/drawingml/2006/main" xmlns:p="http://schemas.openxmlformats.org/presentationml/2006/main" xmlns:r="http://schemas.openxmlformats.org/officeDocument/2006/relationships">
+  <p:cSld>
+    <p:bg>
+      <p:bgPr>
+        <a:solidFill>
           <a:srgbClr val="F5EFE3"/>
         </a:solidFill>
         <a:effectLst/>
@@ -6873,6 +7297,40 @@
         </p:nvSpPr>
         <p:spPr>
           <a:xfrm>
+            <a:off x="822960" y="548640"/>
+            <a:ext cx="10515600" cy="457200"/>
+          </a:xfrm>
+          <a:prstGeom prst="rect">
+            <a:avLst/>
+          </a:prstGeom>
+          <a:noFill/>
+        </p:spPr>
+        <p:txBody>
+          <a:bodyPr wrap="none">
+            <a:spAutoFit/>
+          </a:bodyPr>
+          <a:lstStyle/>
+          <a:p>
+            <a:r>
+              <a:rPr sz="1500" b="1">
+                <a:solidFill>
+                  <a:srgbClr val="C2A46D"/>
+                </a:solidFill>
+                <a:latin typeface="Lora"/>
+              </a:rPr>
+              <a:t>THE I'M INVISIBLE PATTERN</a:t>
+            </a:r>
+          </a:p>
+        </p:txBody>
+      </p:sp>
+      <p:sp>
+        <p:nvSpPr>
+          <p:cNvPr id="3" name="TextBox 2"/>
+          <p:cNvSpPr txBox="1"/>
+          <p:nvPr/>
+        </p:nvSpPr>
+        <p:spPr>
+          <a:xfrm>
             <a:off x="822960" y="1005840"/>
             <a:ext cx="10515600" cy="2926080"/>
           </a:xfrm>
@@ -6901,7 +7359,7 @@
       </p:sp>
       <p:sp>
         <p:nvSpPr>
-          <p:cNvPr id="3" name="Rectangle 2"/>
+          <p:cNvPr id="4" name="Rectangle 3"/>
           <p:cNvSpPr/>
           <p:nvPr/>
         </p:nvSpPr>
@@ -6945,7 +7403,7 @@
       </p:sp>
       <p:sp>
         <p:nvSpPr>
-          <p:cNvPr id="4" name="TextBox 3"/>
+          <p:cNvPr id="5" name="TextBox 4"/>
           <p:cNvSpPr txBox="1"/>
           <p:nvPr/>
         </p:nvSpPr>
@@ -6977,7 +7435,7 @@
                 </a:solidFill>
                 <a:latin typeface="Lora"/>
               </a:rPr>
-              <a:t>•  We hide our own thoughts and feelings.</a:t>
+              <a:t>•  My attention is on everyone but me.</a:t>
             </a:r>
           </a:p>
           <a:p>
@@ -6993,7 +7451,7 @@
                 </a:solidFill>
                 <a:latin typeface="Lora"/>
               </a:rPr>
-              <a:t>•  We mirror everyone else.</a:t>
+              <a:t>•  I assume you can see what I never said.</a:t>
             </a:r>
           </a:p>
           <a:p>
@@ -7009,7 +7467,7 @@
                 </a:solidFill>
                 <a:latin typeface="Lora"/>
               </a:rPr>
-              <a:t>•  We hint instead of ask.</a:t>
+              <a:t>•  I serve until I'm empty.</a:t>
             </a:r>
           </a:p>
           <a:p>
@@ -7025,14 +7483,14 @@
                 </a:solidFill>
                 <a:latin typeface="Lora"/>
               </a:rPr>
-              <a:t>•  We give from empty and call it love.</a:t>
-            </a:r>
-          </a:p>
-        </p:txBody>
-      </p:sp>
-      <p:sp>
-        <p:nvSpPr>
-          <p:cNvPr id="5" name="TextBox 4"/>
+              <a:t>•  I wait, quietly, to be discovered.</a:t>
+            </a:r>
+          </a:p>
+        </p:txBody>
+      </p:sp>
+      <p:sp>
+        <p:nvSpPr>
+          <p:cNvPr id="6" name="TextBox 5"/>
           <p:cNvSpPr txBox="1"/>
           <p:nvPr/>
         </p:nvSpPr>

</xml_diff>

<commit_message>
Apply Tarisha's Session 1 edits and remove italics for readability
Body text now upright (no italics). Session 1 wording updates: sentence-case
title, 'There's no right or wrong way' circle agreement, 'Softening practice',
expanded resentment loop, tightened hard-truth, 'doorway into your desires',
'My deepest desire is... / Explore in pairs', 'seven levels deep'.

Co-Authored-By: Claude Opus 4.8 <noreply@anthropic.com>
Claude-Session: https://claude.ai/code/session_01FhNN1xnUyELSQ3xs2X22yA
</commit_message>
<xml_diff>
--- a/content/sessions/slides/Session-1-Coming-Home-to-Yourself.pptx
+++ b/content/sessions/slides/Session-1-Coming-Home-to-Yourself.pptx
@@ -3180,7 +3180,7 @@
                 </a:solidFill>
                 <a:latin typeface="Marcellus"/>
               </a:rPr>
-              <a:t>Coming Home to Yourself</a:t>
+              <a:t>Coming home to yourself</a:t>
             </a:r>
           </a:p>
         </p:txBody>
@@ -3257,7 +3257,7 @@
               </a:spcAft>
             </a:pPr>
             <a:r>
-              <a:rPr sz="2700" i="1">
+              <a:rPr sz="2700" i="0">
                 <a:solidFill>
                   <a:srgbClr val="F5EFE3"/>
                 </a:solidFill>
@@ -3357,7 +3357,7 @@
                 </a:solidFill>
                 <a:latin typeface="Marcellus"/>
               </a:rPr>
-              <a:t>The hard truth, said gently</a:t>
+              <a:t>The hard truth</a:t>
             </a:r>
           </a:p>
         </p:txBody>
@@ -3434,13 +3434,13 @@
               </a:spcAft>
             </a:pPr>
             <a:r>
-              <a:rPr sz="2700" i="1">
+              <a:rPr sz="2700" i="0">
                 <a:solidFill>
                   <a:srgbClr val="15110D"/>
                 </a:solidFill>
                 <a:latin typeface="Lora"/>
               </a:rPr>
-              <a:t>You have taught the people around you exactly how much of you to see. A habit, not a fact. And tonight we start practising the opposite.</a:t>
+              <a:t>You have taught the people around you exactly how much of you to see. And tonight we start practising the opposite.</a:t>
             </a:r>
           </a:p>
         </p:txBody>
@@ -3645,7 +3645,7 @@
               </a:spcAft>
             </a:pPr>
             <a:r>
-              <a:rPr sz="2700" i="1">
+              <a:rPr sz="2700" i="0">
                 <a:solidFill>
                   <a:srgbClr val="15110D"/>
                 </a:solidFill>
@@ -4115,13 +4115,13 @@
               </a:spcAft>
             </a:pPr>
             <a:r>
-              <a:rPr sz="2700" i="1">
+              <a:rPr sz="2700" i="0">
                 <a:solidFill>
                   <a:srgbClr val="F5EFE3"/>
                 </a:solidFill>
                 <a:latin typeface="Lora"/>
               </a:rPr>
-              <a:t>The no is the doorway. Your body already knows it.</a:t>
+              <a:t>The no is the doorway into your desires. Your body already knows it.</a:t>
             </a:r>
           </a:p>
         </p:txBody>
@@ -4569,7 +4569,7 @@
               </a:spcAft>
             </a:pPr>
             <a:r>
-              <a:rPr sz="2700" i="1">
+              <a:rPr sz="2700" i="0">
                 <a:solidFill>
                   <a:srgbClr val="F5EFE3"/>
                 </a:solidFill>
@@ -4946,7 +4946,7 @@
                 </a:solidFill>
                 <a:latin typeface="Marcellus"/>
               </a:rPr>
-              <a:t>My deepest desire</a:t>
+              <a:t>My deepest desire is...</a:t>
             </a:r>
           </a:p>
         </p:txBody>
@@ -5023,13 +5023,13 @@
               </a:spcAft>
             </a:pPr>
             <a:r>
-              <a:rPr sz="2700" i="1">
+              <a:rPr sz="2700" i="0">
                 <a:solidFill>
                   <a:srgbClr val="F5EFE3"/>
                 </a:solidFill>
                 <a:latin typeface="Lora"/>
               </a:rPr>
-              <a:t>Underneath the want is the desire your whole life is organised around.</a:t>
+              <a:t>Explore in pairs.</a:t>
             </a:r>
           </a:p>
         </p:txBody>
@@ -5200,13 +5200,13 @@
               </a:spcAft>
             </a:pPr>
             <a:r>
-              <a:rPr sz="2700" i="1">
+              <a:rPr sz="2700" i="0">
                 <a:solidFill>
                   <a:srgbClr val="F5EFE3"/>
                 </a:solidFill>
                 <a:latin typeface="Lora"/>
               </a:rPr>
-              <a:t>And if I had that, what would it give me? Keep asking. Reach for the true answer, not the impressive one.</a:t>
+              <a:t>And if I had that, what would it give me? Keep asking, going seven levels deep.</a:t>
             </a:r>
           </a:p>
         </p:txBody>
@@ -5377,7 +5377,7 @@
               </a:spcAft>
             </a:pPr>
             <a:r>
-              <a:rPr sz="2700" i="1">
+              <a:rPr sz="2700" i="0">
                 <a:solidFill>
                   <a:srgbClr val="15110D"/>
                 </a:solidFill>
@@ -5554,7 +5554,7 @@
               </a:spcAft>
             </a:pPr>
             <a:r>
-              <a:rPr sz="2700" i="1">
+              <a:rPr sz="2700" i="0">
                 <a:solidFill>
                   <a:srgbClr val="15110D"/>
                 </a:solidFill>
@@ -5765,7 +5765,7 @@
               </a:spcAft>
             </a:pPr>
             <a:r>
-              <a:rPr sz="2700" i="1">
+              <a:rPr sz="2700" i="0">
                 <a:solidFill>
                   <a:srgbClr val="F5EFE3"/>
                 </a:solidFill>
@@ -5942,7 +5942,7 @@
               </a:spcAft>
             </a:pPr>
             <a:r>
-              <a:rPr sz="2700" i="1">
+              <a:rPr sz="2700" i="0">
                 <a:solidFill>
                   <a:srgbClr val="F5EFE3"/>
                 </a:solidFill>
@@ -6434,7 +6434,7 @@
                 </a:solidFill>
                 <a:latin typeface="Lora"/>
               </a:rPr>
-              <a:t>•  You can always pass.</a:t>
+              <a:t>•  There's no right or wrong way.</a:t>
             </a:r>
           </a:p>
           <a:p>
@@ -6544,7 +6544,7 @@
                 </a:solidFill>
                 <a:latin typeface="Marcellus"/>
               </a:rPr>
-              <a:t>Soften your jaw.</a:t>
+              <a:t>Softening practice.</a:t>
             </a:r>
           </a:p>
         </p:txBody>
@@ -6621,7 +6621,7 @@
               </a:spcAft>
             </a:pPr>
             <a:r>
-              <a:rPr sz="2700" i="1">
+              <a:rPr sz="2700" i="0">
                 <a:solidFill>
                   <a:srgbClr val="F5EFE3"/>
                 </a:solidFill>
@@ -7007,7 +7007,7 @@
               </a:spcAft>
             </a:pPr>
             <a:r>
-              <a:rPr sz="2700" i="1">
+              <a:rPr sz="2700" i="0">
                 <a:solidFill>
                   <a:srgbClr val="15110D"/>
                 </a:solidFill>
@@ -7218,7 +7218,7 @@
               </a:spcAft>
             </a:pPr>
             <a:r>
-              <a:rPr sz="2700" i="1">
+              <a:rPr sz="2700" i="0">
                 <a:solidFill>
                   <a:srgbClr val="F5EFE3"/>
                 </a:solidFill>
@@ -7654,13 +7654,13 @@
               </a:spcAft>
             </a:pPr>
             <a:r>
-              <a:rPr sz="2700" i="1">
+              <a:rPr sz="2700" i="0">
                 <a:solidFill>
                   <a:srgbClr val="F5EFE3"/>
                 </a:solidFill>
                 <a:latin typeface="Lora"/>
               </a:rPr>
-              <a:t>Believe you're invisible → disappear yourself → they don't see you → you feel invisible. The belief builds its own proof.</a:t>
+              <a:t>Believe no-one cares or being seen is unsafe → disappear yourself while focusing on others' needs → they don't see you → you feel invisible → you become resentful → you ask with accusation and frustration → they defend and don't hear you → you feel invisible and uncared for → resentful again... The belief builds its own proof.</a:t>
             </a:r>
           </a:p>
         </p:txBody>

</xml_diff>